<commit_message>
sync user flow deck details with live product
</commit_message>
<xml_diff>
--- a/output/doc/user-flow-decks/01-platform-overview-and-role-map.pptx
+++ b/output/doc/user-flow-decks/01-platform-overview-and-role-map.pptx
@@ -5815,7 +5815,7 @@
         <p:spPr>
           <a:xfrm>
             <a:off x="749808" y="1097280"/>
-            <a:ext cx="4023360" cy="256032"/>
+            <a:ext cx="3931920" cy="4754880"/>
           </a:xfrm>
           <a:prstGeom prst="rect">
             <a:avLst/>
@@ -5823,12 +5823,19 @@
           <a:noFill/>
         </p:spPr>
         <p:txBody>
-          <a:bodyPr wrap="square" anchor="t">
+          <a:bodyPr wrap="square" lIns="0" rIns="0" tIns="0" bIns="0">
             <a:spAutoFit/>
           </a:bodyPr>
           <a:lstStyle/>
           <a:p>
-            <a:pPr algn="l"/>
+            <a:pPr algn="l">
+              <a:spcBef>
+                <a:spcPts val="0"/>
+              </a:spcBef>
+              <a:spcAft>
+                <a:spcPts val="200"/>
+              </a:spcAft>
+            </a:pPr>
             <a:r>
               <a:rPr sz="1200" b="1">
                 <a:solidFill>
@@ -5839,33 +5846,20 @@
               <a:t>User action</a:t>
             </a:r>
           </a:p>
-        </p:txBody>
-      </p:sp>
-      <p:sp>
-        <p:nvSpPr>
-          <p:cNvPr id="8" name="TextBox 7"/>
-          <p:cNvSpPr txBox="1"/>
-          <p:nvPr/>
-        </p:nvSpPr>
-        <p:spPr>
-          <a:xfrm>
-            <a:off x="749808" y="1353312"/>
-            <a:ext cx="3931920" cy="621792"/>
-          </a:xfrm>
-          <a:prstGeom prst="rect">
-            <a:avLst/>
-          </a:prstGeom>
-          <a:noFill/>
-        </p:spPr>
-        <p:txBody>
-          <a:bodyPr wrap="square" anchor="t">
-            <a:spAutoFit/>
-          </a:bodyPr>
-          <a:lstStyle/>
-          <a:p>
-            <a:pPr algn="l"/>
-            <a:r>
-              <a:rPr sz="1600" b="0">
+          <a:p>
+            <a:pPr algn="l">
+              <a:lnSpc>
+                <a:spcPct val="110000"/>
+              </a:lnSpc>
+              <a:spcBef>
+                <a:spcPts val="0"/>
+              </a:spcBef>
+              <a:spcAft>
+                <a:spcPts val="800"/>
+              </a:spcAft>
+            </a:pPr>
+            <a:r>
+              <a:rPr sz="1300">
                 <a:solidFill>
                   <a:srgbClr val="102A43"/>
                 </a:solidFill>
@@ -5874,31 +5868,15 @@
               <a:t>Start from the route that matches the role: publisher link, authenticated Manage Data Panel, field-rep login page, or public short link.</a:t>
             </a:r>
           </a:p>
-        </p:txBody>
-      </p:sp>
-      <p:sp>
-        <p:nvSpPr>
-          <p:cNvPr id="9" name="TextBox 8"/>
-          <p:cNvSpPr txBox="1"/>
-          <p:nvPr/>
-        </p:nvSpPr>
-        <p:spPr>
-          <a:xfrm>
-            <a:off x="749808" y="2011680"/>
-            <a:ext cx="4023360" cy="256032"/>
-          </a:xfrm>
-          <a:prstGeom prst="rect">
-            <a:avLst/>
-          </a:prstGeom>
-          <a:noFill/>
-        </p:spPr>
-        <p:txBody>
-          <a:bodyPr wrap="square" anchor="t">
-            <a:spAutoFit/>
-          </a:bodyPr>
-          <a:lstStyle/>
-          <a:p>
-            <a:pPr algn="l"/>
+          <a:p>
+            <a:pPr algn="l">
+              <a:spcBef>
+                <a:spcPts val="0"/>
+              </a:spcBef>
+              <a:spcAft>
+                <a:spcPts val="200"/>
+              </a:spcAft>
+            </a:pPr>
             <a:r>
               <a:rPr sz="1200" b="1">
                 <a:solidFill>
@@ -5909,33 +5887,20 @@
               <a:t>What appears on screen</a:t>
             </a:r>
           </a:p>
-        </p:txBody>
-      </p:sp>
-      <p:sp>
-        <p:nvSpPr>
-          <p:cNvPr id="10" name="TextBox 9"/>
-          <p:cNvSpPr txBox="1"/>
-          <p:nvPr/>
-        </p:nvSpPr>
-        <p:spPr>
-          <a:xfrm>
-            <a:off x="749808" y="2267712"/>
-            <a:ext cx="3931920" cy="713232"/>
-          </a:xfrm>
-          <a:prstGeom prst="rect">
-            <a:avLst/>
-          </a:prstGeom>
-          <a:noFill/>
-        </p:spPr>
-        <p:txBody>
-          <a:bodyPr wrap="square" anchor="t">
-            <a:spAutoFit/>
-          </a:bodyPr>
-          <a:lstStyle/>
-          <a:p>
-            <a:pPr algn="l"/>
-            <a:r>
-              <a:rPr sz="1600" b="0">
+          <a:p>
+            <a:pPr algn="l">
+              <a:lnSpc>
+                <a:spcPct val="110000"/>
+              </a:lnSpc>
+              <a:spcBef>
+                <a:spcPts val="0"/>
+              </a:spcBef>
+              <a:spcAft>
+                <a:spcPts val="800"/>
+              </a:spcAft>
+            </a:pPr>
+            <a:r>
+              <a:rPr sz="1300">
                 <a:solidFill>
                   <a:srgbClr val="102A43"/>
                 </a:solidFill>
@@ -5944,31 +5909,15 @@
               <a:t>A role-appropriate screen with the campaign context already embedded or selected.</a:t>
             </a:r>
           </a:p>
-        </p:txBody>
-      </p:sp>
-      <p:sp>
-        <p:nvSpPr>
-          <p:cNvPr id="11" name="TextBox 10"/>
-          <p:cNvSpPr txBox="1"/>
-          <p:nvPr/>
-        </p:nvSpPr>
-        <p:spPr>
-          <a:xfrm>
-            <a:off x="749808" y="3063240"/>
-            <a:ext cx="4023360" cy="256032"/>
-          </a:xfrm>
-          <a:prstGeom prst="rect">
-            <a:avLst/>
-          </a:prstGeom>
-          <a:noFill/>
-        </p:spPr>
-        <p:txBody>
-          <a:bodyPr wrap="square" anchor="t">
-            <a:spAutoFit/>
-          </a:bodyPr>
-          <a:lstStyle/>
-          <a:p>
-            <a:pPr algn="l"/>
+          <a:p>
+            <a:pPr algn="l">
+              <a:spcBef>
+                <a:spcPts val="0"/>
+              </a:spcBef>
+              <a:spcAft>
+                <a:spcPts val="200"/>
+              </a:spcAft>
+            </a:pPr>
             <a:r>
               <a:rPr sz="1200" b="1">
                 <a:solidFill>
@@ -5979,33 +5928,20 @@
               <a:t>Why it matters</a:t>
             </a:r>
           </a:p>
-        </p:txBody>
-      </p:sp>
-      <p:sp>
-        <p:nvSpPr>
-          <p:cNvPr id="12" name="TextBox 11"/>
-          <p:cNvSpPr txBox="1"/>
-          <p:nvPr/>
-        </p:nvSpPr>
-        <p:spPr>
-          <a:xfrm>
-            <a:off x="749808" y="3319272"/>
-            <a:ext cx="3931920" cy="640080"/>
-          </a:xfrm>
-          <a:prstGeom prst="rect">
-            <a:avLst/>
-          </a:prstGeom>
-          <a:noFill/>
-        </p:spPr>
-        <p:txBody>
-          <a:bodyPr wrap="square" anchor="t">
-            <a:spAutoFit/>
-          </a:bodyPr>
-          <a:lstStyle/>
-          <a:p>
-            <a:pPr algn="l"/>
-            <a:r>
-              <a:rPr sz="1500" b="0">
+          <a:p>
+            <a:pPr algn="l">
+              <a:lnSpc>
+                <a:spcPct val="110000"/>
+              </a:lnSpc>
+              <a:spcBef>
+                <a:spcPts val="0"/>
+              </a:spcBef>
+              <a:spcAft>
+                <a:spcPts val="800"/>
+              </a:spcAft>
+            </a:pPr>
+            <a:r>
+              <a:rPr sz="1300">
                 <a:solidFill>
                   <a:srgbClr val="102A43"/>
                 </a:solidFill>
@@ -6014,31 +5950,15 @@
               <a:t>The system is intentionally route-driven. The entry point determines which database data is consulted and which actions are available next.</a:t>
             </a:r>
           </a:p>
-        </p:txBody>
-      </p:sp>
-      <p:sp>
-        <p:nvSpPr>
-          <p:cNvPr id="13" name="TextBox 12"/>
-          <p:cNvSpPr txBox="1"/>
-          <p:nvPr/>
-        </p:nvSpPr>
-        <p:spPr>
-          <a:xfrm>
-            <a:off x="749808" y="4069080"/>
-            <a:ext cx="4023360" cy="256032"/>
-          </a:xfrm>
-          <a:prstGeom prst="rect">
-            <a:avLst/>
-          </a:prstGeom>
-          <a:noFill/>
-        </p:spPr>
-        <p:txBody>
-          <a:bodyPr wrap="square" anchor="t">
-            <a:spAutoFit/>
-          </a:bodyPr>
-          <a:lstStyle/>
-          <a:p>
-            <a:pPr algn="l"/>
+          <a:p>
+            <a:pPr algn="l">
+              <a:spcBef>
+                <a:spcPts val="0"/>
+              </a:spcBef>
+              <a:spcAft>
+                <a:spcPts val="200"/>
+              </a:spcAft>
+            </a:pPr>
             <a:r>
               <a:rPr sz="1200" b="1">
                 <a:solidFill>
@@ -6049,33 +5969,20 @@
               <a:t>Expected result</a:t>
             </a:r>
           </a:p>
-        </p:txBody>
-      </p:sp>
-      <p:sp>
-        <p:nvSpPr>
-          <p:cNvPr id="14" name="TextBox 13"/>
-          <p:cNvSpPr txBox="1"/>
-          <p:nvPr/>
-        </p:nvSpPr>
-        <p:spPr>
-          <a:xfrm>
-            <a:off x="749808" y="4325112"/>
-            <a:ext cx="3931920" cy="566928"/>
-          </a:xfrm>
-          <a:prstGeom prst="rect">
-            <a:avLst/>
-          </a:prstGeom>
-          <a:noFill/>
-        </p:spPr>
-        <p:txBody>
-          <a:bodyPr wrap="square" anchor="t">
-            <a:spAutoFit/>
-          </a:bodyPr>
-          <a:lstStyle/>
-          <a:p>
-            <a:pPr algn="l"/>
-            <a:r>
-              <a:rPr sz="1500" b="0">
+          <a:p>
+            <a:pPr algn="l">
+              <a:lnSpc>
+                <a:spcPct val="110000"/>
+              </a:lnSpc>
+              <a:spcBef>
+                <a:spcPts val="0"/>
+              </a:spcBef>
+              <a:spcAft>
+                <a:spcPts val="800"/>
+              </a:spcAft>
+            </a:pPr>
+            <a:r>
+              <a:rPr sz="1300">
                 <a:solidFill>
                   <a:srgbClr val="102A43"/>
                 </a:solidFill>
@@ -6084,31 +5991,15 @@
               <a:t>The user lands on the correct role surface without manually stitching together URLs.</a:t>
             </a:r>
           </a:p>
-        </p:txBody>
-      </p:sp>
-      <p:sp>
-        <p:nvSpPr>
-          <p:cNvPr id="15" name="TextBox 14"/>
-          <p:cNvSpPr txBox="1"/>
-          <p:nvPr/>
-        </p:nvSpPr>
-        <p:spPr>
-          <a:xfrm>
-            <a:off x="749808" y="4965192"/>
-            <a:ext cx="4023360" cy="256032"/>
-          </a:xfrm>
-          <a:prstGeom prst="rect">
-            <a:avLst/>
-          </a:prstGeom>
-          <a:noFill/>
-        </p:spPr>
-        <p:txBody>
-          <a:bodyPr wrap="square" anchor="t">
-            <a:spAutoFit/>
-          </a:bodyPr>
-          <a:lstStyle/>
-          <a:p>
-            <a:pPr algn="l"/>
+          <a:p>
+            <a:pPr algn="l">
+              <a:spcBef>
+                <a:spcPts val="0"/>
+              </a:spcBef>
+              <a:spcAft>
+                <a:spcPts val="200"/>
+              </a:spcAft>
+            </a:pPr>
             <a:r>
               <a:rPr sz="1200" b="1">
                 <a:solidFill>
@@ -6119,33 +6010,20 @@
               <a:t>Trainer note</a:t>
             </a:r>
           </a:p>
-        </p:txBody>
-      </p:sp>
-      <p:sp>
-        <p:nvSpPr>
-          <p:cNvPr id="16" name="TextBox 15"/>
-          <p:cNvSpPr txBox="1"/>
-          <p:nvPr/>
-        </p:nvSpPr>
-        <p:spPr>
-          <a:xfrm>
-            <a:off x="749808" y="5212080"/>
-            <a:ext cx="3931920" cy="640080"/>
-          </a:xfrm>
-          <a:prstGeom prst="rect">
-            <a:avLst/>
-          </a:prstGeom>
-          <a:noFill/>
-        </p:spPr>
-        <p:txBody>
-          <a:bodyPr wrap="square" anchor="t">
-            <a:spAutoFit/>
-          </a:bodyPr>
-          <a:lstStyle/>
-          <a:p>
-            <a:pPr algn="l"/>
-            <a:r>
-              <a:rPr sz="1300" b="0">
+          <a:p>
+            <a:pPr algn="l">
+              <a:lnSpc>
+                <a:spcPct val="110000"/>
+              </a:lnSpc>
+              <a:spcBef>
+                <a:spcPts val="0"/>
+              </a:spcBef>
+              <a:spcAft>
+                <a:spcPts val="0"/>
+              </a:spcAft>
+            </a:pPr>
+            <a:r>
+              <a:rPr sz="1200">
                 <a:solidFill>
                   <a:srgbClr val="52667A"/>
                 </a:solidFill>
@@ -6158,7 +6036,7 @@
       </p:sp>
       <p:sp>
         <p:nvSpPr>
-          <p:cNvPr id="17" name="Rounded Rectangle 16"/>
+          <p:cNvPr id="8" name="Rounded Rectangle 7"/>
           <p:cNvSpPr/>
           <p:nvPr/>
         </p:nvSpPr>
@@ -6203,7 +6081,7 @@
       </p:sp>
       <p:sp>
         <p:nvSpPr>
-          <p:cNvPr id="18" name="TextBox 17"/>
+          <p:cNvPr id="9" name="TextBox 8"/>
           <p:cNvSpPr txBox="1"/>
           <p:nvPr/>
         </p:nvSpPr>
@@ -6238,7 +6116,7 @@
       </p:sp>
       <p:pic>
         <p:nvPicPr>
-          <p:cNvPr id="19" name="Picture 18" descr="platform-home.png"/>
+          <p:cNvPr id="10" name="Picture 9" descr="platform-home.png"/>
           <p:cNvPicPr>
             <a:picLocks noChangeAspect="1"/>
           </p:cNvPicPr>
@@ -6262,7 +6140,7 @@
       </p:pic>
       <p:sp>
         <p:nvSpPr>
-          <p:cNvPr id="20" name="TextBox 19"/>
+          <p:cNvPr id="11" name="TextBox 10"/>
           <p:cNvSpPr txBox="1"/>
           <p:nvPr/>
         </p:nvSpPr>
@@ -6297,7 +6175,7 @@
       </p:sp>
       <p:sp>
         <p:nvSpPr>
-          <p:cNvPr id="21" name="TextBox 20"/>
+          <p:cNvPr id="12" name="TextBox 11"/>
           <p:cNvSpPr txBox="1"/>
           <p:nvPr/>
         </p:nvSpPr>
@@ -6570,7 +6448,7 @@
         <p:spPr>
           <a:xfrm>
             <a:off x="749808" y="1097280"/>
-            <a:ext cx="4023360" cy="256032"/>
+            <a:ext cx="3931920" cy="4754880"/>
           </a:xfrm>
           <a:prstGeom prst="rect">
             <a:avLst/>
@@ -6578,12 +6456,19 @@
           <a:noFill/>
         </p:spPr>
         <p:txBody>
-          <a:bodyPr wrap="square" anchor="t">
+          <a:bodyPr wrap="square" lIns="0" rIns="0" tIns="0" bIns="0">
             <a:spAutoFit/>
           </a:bodyPr>
           <a:lstStyle/>
           <a:p>
-            <a:pPr algn="l"/>
+            <a:pPr algn="l">
+              <a:spcBef>
+                <a:spcPts val="0"/>
+              </a:spcBef>
+              <a:spcAft>
+                <a:spcPts val="200"/>
+              </a:spcAft>
+            </a:pPr>
             <a:r>
               <a:rPr sz="1200" b="1">
                 <a:solidFill>
@@ -6594,33 +6479,20 @@
               <a:t>User action</a:t>
             </a:r>
           </a:p>
-        </p:txBody>
-      </p:sp>
-      <p:sp>
-        <p:nvSpPr>
-          <p:cNvPr id="8" name="TextBox 7"/>
-          <p:cNvSpPr txBox="1"/>
-          <p:nvPr/>
-        </p:nvSpPr>
-        <p:spPr>
-          <a:xfrm>
-            <a:off x="749808" y="1353312"/>
-            <a:ext cx="3931920" cy="621792"/>
-          </a:xfrm>
-          <a:prstGeom prst="rect">
-            <a:avLst/>
-          </a:prstGeom>
-          <a:noFill/>
-        </p:spPr>
-        <p:txBody>
-          <a:bodyPr wrap="square" anchor="t">
-            <a:spAutoFit/>
-          </a:bodyPr>
-          <a:lstStyle/>
-          <a:p>
-            <a:pPr algn="l"/>
-            <a:r>
-              <a:rPr sz="1600" b="0">
+          <a:p>
+            <a:pPr algn="l">
+              <a:lnSpc>
+                <a:spcPct val="110000"/>
+              </a:lnSpc>
+              <a:spcBef>
+                <a:spcPts val="0"/>
+              </a:spcBef>
+              <a:spcAft>
+                <a:spcPts val="800"/>
+              </a:spcAft>
+            </a:pPr>
+            <a:r>
+              <a:rPr sz="1300">
                 <a:solidFill>
                   <a:srgbClr val="102A43"/>
                 </a:solidFill>
@@ -6629,31 +6501,15 @@
               <a:t>Open the Manage Data Panel or the publisher flow for a specific brand campaign.</a:t>
             </a:r>
           </a:p>
-        </p:txBody>
-      </p:sp>
-      <p:sp>
-        <p:nvSpPr>
-          <p:cNvPr id="9" name="TextBox 8"/>
-          <p:cNvSpPr txBox="1"/>
-          <p:nvPr/>
-        </p:nvSpPr>
-        <p:spPr>
-          <a:xfrm>
-            <a:off x="749808" y="2011680"/>
-            <a:ext cx="4023360" cy="256032"/>
-          </a:xfrm>
-          <a:prstGeom prst="rect">
-            <a:avLst/>
-          </a:prstGeom>
-          <a:noFill/>
-        </p:spPr>
-        <p:txBody>
-          <a:bodyPr wrap="square" anchor="t">
-            <a:spAutoFit/>
-          </a:bodyPr>
-          <a:lstStyle/>
-          <a:p>
-            <a:pPr algn="l"/>
+          <a:p>
+            <a:pPr algn="l">
+              <a:spcBef>
+                <a:spcPts val="0"/>
+              </a:spcBef>
+              <a:spcAft>
+                <a:spcPts val="200"/>
+              </a:spcAft>
+            </a:pPr>
             <a:r>
               <a:rPr sz="1200" b="1">
                 <a:solidFill>
@@ -6664,33 +6520,20 @@
               <a:t>What appears on screen</a:t>
             </a:r>
           </a:p>
-        </p:txBody>
-      </p:sp>
-      <p:sp>
-        <p:nvSpPr>
-          <p:cNvPr id="10" name="TextBox 9"/>
-          <p:cNvSpPr txBox="1"/>
-          <p:nvPr/>
-        </p:nvSpPr>
-        <p:spPr>
-          <a:xfrm>
-            <a:off x="749808" y="2267712"/>
-            <a:ext cx="3931920" cy="713232"/>
-          </a:xfrm>
-          <a:prstGeom prst="rect">
-            <a:avLst/>
-          </a:prstGeom>
-          <a:noFill/>
-        </p:spPr>
-        <p:txBody>
-          <a:bodyPr wrap="square" anchor="t">
-            <a:spAutoFit/>
-          </a:bodyPr>
-          <a:lstStyle/>
-          <a:p>
-            <a:pPr algn="l"/>
-            <a:r>
-              <a:rPr sz="1600" b="0">
+          <a:p>
+            <a:pPr algn="l">
+              <a:lnSpc>
+                <a:spcPct val="110000"/>
+              </a:lnSpc>
+              <a:spcBef>
+                <a:spcPts val="0"/>
+              </a:spcBef>
+              <a:spcAft>
+                <a:spcPts val="800"/>
+              </a:spcAft>
+            </a:pPr>
+            <a:r>
+              <a:rPr sz="1300">
                 <a:solidFill>
                   <a:srgbClr val="102A43"/>
                 </a:solidFill>
@@ -6699,31 +6542,15 @@
               <a:t>A campaign inventory or campaign form populated with master-owned context such as brand name, company name, and doctor count.</a:t>
             </a:r>
           </a:p>
-        </p:txBody>
-      </p:sp>
-      <p:sp>
-        <p:nvSpPr>
-          <p:cNvPr id="11" name="TextBox 10"/>
-          <p:cNvSpPr txBox="1"/>
-          <p:nvPr/>
-        </p:nvSpPr>
-        <p:spPr>
-          <a:xfrm>
-            <a:off x="749808" y="3063240"/>
-            <a:ext cx="4023360" cy="256032"/>
-          </a:xfrm>
-          <a:prstGeom prst="rect">
-            <a:avLst/>
-          </a:prstGeom>
-          <a:noFill/>
-        </p:spPr>
-        <p:txBody>
-          <a:bodyPr wrap="square" anchor="t">
-            <a:spAutoFit/>
-          </a:bodyPr>
-          <a:lstStyle/>
-          <a:p>
-            <a:pPr algn="l"/>
+          <a:p>
+            <a:pPr algn="l">
+              <a:spcBef>
+                <a:spcPts val="0"/>
+              </a:spcBef>
+              <a:spcAft>
+                <a:spcPts val="200"/>
+              </a:spcAft>
+            </a:pPr>
             <a:r>
               <a:rPr sz="1200" b="1">
                 <a:solidFill>
@@ -6734,33 +6561,20 @@
               <a:t>Why it matters</a:t>
             </a:r>
           </a:p>
-        </p:txBody>
-      </p:sp>
-      <p:sp>
-        <p:nvSpPr>
-          <p:cNvPr id="12" name="TextBox 11"/>
-          <p:cNvSpPr txBox="1"/>
-          <p:nvPr/>
-        </p:nvSpPr>
-        <p:spPr>
-          <a:xfrm>
-            <a:off x="749808" y="3319272"/>
-            <a:ext cx="3931920" cy="640080"/>
-          </a:xfrm>
-          <a:prstGeom prst="rect">
-            <a:avLst/>
-          </a:prstGeom>
-          <a:noFill/>
-        </p:spPr>
-        <p:txBody>
-          <a:bodyPr wrap="square" anchor="t">
-            <a:spAutoFit/>
-          </a:bodyPr>
-          <a:lstStyle/>
-          <a:p>
-            <a:pPr algn="l"/>
-            <a:r>
-              <a:rPr sz="1500" b="0">
+          <a:p>
+            <a:pPr algn="l">
+              <a:lnSpc>
+                <a:spcPct val="110000"/>
+              </a:lnSpc>
+              <a:spcBef>
+                <a:spcPts val="0"/>
+              </a:spcBef>
+              <a:spcAft>
+                <a:spcPts val="800"/>
+              </a:spcAft>
+            </a:pPr>
+            <a:r>
+              <a:rPr sz="1300">
                 <a:solidFill>
                   <a:srgbClr val="102A43"/>
                 </a:solidFill>
@@ -6769,31 +6583,15 @@
               <a:t>This is the handoff from source-of-truth campaign definitions into the operational portal where the team can manage assets and distribution.</a:t>
             </a:r>
           </a:p>
-        </p:txBody>
-      </p:sp>
-      <p:sp>
-        <p:nvSpPr>
-          <p:cNvPr id="13" name="TextBox 12"/>
-          <p:cNvSpPr txBox="1"/>
-          <p:nvPr/>
-        </p:nvSpPr>
-        <p:spPr>
-          <a:xfrm>
-            <a:off x="749808" y="4069080"/>
-            <a:ext cx="4023360" cy="256032"/>
-          </a:xfrm>
-          <a:prstGeom prst="rect">
-            <a:avLst/>
-          </a:prstGeom>
-          <a:noFill/>
-        </p:spPr>
-        <p:txBody>
-          <a:bodyPr wrap="square" anchor="t">
-            <a:spAutoFit/>
-          </a:bodyPr>
-          <a:lstStyle/>
-          <a:p>
-            <a:pPr algn="l"/>
+          <a:p>
+            <a:pPr algn="l">
+              <a:spcBef>
+                <a:spcPts val="0"/>
+              </a:spcBef>
+              <a:spcAft>
+                <a:spcPts val="200"/>
+              </a:spcAft>
+            </a:pPr>
             <a:r>
               <a:rPr sz="1200" b="1">
                 <a:solidFill>
@@ -6804,33 +6602,20 @@
               <a:t>Expected result</a:t>
             </a:r>
           </a:p>
-        </p:txBody>
-      </p:sp>
-      <p:sp>
-        <p:nvSpPr>
-          <p:cNvPr id="14" name="TextBox 13"/>
-          <p:cNvSpPr txBox="1"/>
-          <p:nvPr/>
-        </p:nvSpPr>
-        <p:spPr>
-          <a:xfrm>
-            <a:off x="749808" y="4325112"/>
-            <a:ext cx="3931920" cy="566928"/>
-          </a:xfrm>
-          <a:prstGeom prst="rect">
-            <a:avLst/>
-          </a:prstGeom>
-          <a:noFill/>
-        </p:spPr>
-        <p:txBody>
-          <a:bodyPr wrap="square" anchor="t">
-            <a:spAutoFit/>
-          </a:bodyPr>
-          <a:lstStyle/>
-          <a:p>
-            <a:pPr algn="l"/>
-            <a:r>
-              <a:rPr sz="1500" b="0">
+          <a:p>
+            <a:pPr algn="l">
+              <a:lnSpc>
+                <a:spcPct val="110000"/>
+              </a:lnSpc>
+              <a:spcBef>
+                <a:spcPts val="0"/>
+              </a:spcBef>
+              <a:spcAft>
+                <a:spcPts val="800"/>
+              </a:spcAft>
+            </a:pPr>
+            <a:r>
+              <a:rPr sz="1300">
                 <a:solidFill>
                   <a:srgbClr val="102A43"/>
                 </a:solidFill>
@@ -6839,31 +6624,15 @@
               <a:t>The campaign is recognizable and ready for collateral, rep, and doctor operations.</a:t>
             </a:r>
           </a:p>
-        </p:txBody>
-      </p:sp>
-      <p:sp>
-        <p:nvSpPr>
-          <p:cNvPr id="15" name="TextBox 14"/>
-          <p:cNvSpPr txBox="1"/>
-          <p:nvPr/>
-        </p:nvSpPr>
-        <p:spPr>
-          <a:xfrm>
-            <a:off x="749808" y="4965192"/>
-            <a:ext cx="4023360" cy="256032"/>
-          </a:xfrm>
-          <a:prstGeom prst="rect">
-            <a:avLst/>
-          </a:prstGeom>
-          <a:noFill/>
-        </p:spPr>
-        <p:txBody>
-          <a:bodyPr wrap="square" anchor="t">
-            <a:spAutoFit/>
-          </a:bodyPr>
-          <a:lstStyle/>
-          <a:p>
-            <a:pPr algn="l"/>
+          <a:p>
+            <a:pPr algn="l">
+              <a:spcBef>
+                <a:spcPts val="0"/>
+              </a:spcBef>
+              <a:spcAft>
+                <a:spcPts val="200"/>
+              </a:spcAft>
+            </a:pPr>
             <a:r>
               <a:rPr sz="1200" b="1">
                 <a:solidFill>
@@ -6874,33 +6643,20 @@
               <a:t>Trainer note</a:t>
             </a:r>
           </a:p>
-        </p:txBody>
-      </p:sp>
-      <p:sp>
-        <p:nvSpPr>
-          <p:cNvPr id="16" name="TextBox 15"/>
-          <p:cNvSpPr txBox="1"/>
-          <p:nvPr/>
-        </p:nvSpPr>
-        <p:spPr>
-          <a:xfrm>
-            <a:off x="749808" y="5212080"/>
-            <a:ext cx="3931920" cy="640080"/>
-          </a:xfrm>
-          <a:prstGeom prst="rect">
-            <a:avLst/>
-          </a:prstGeom>
-          <a:noFill/>
-        </p:spPr>
-        <p:txBody>
-          <a:bodyPr wrap="square" anchor="t">
-            <a:spAutoFit/>
-          </a:bodyPr>
-          <a:lstStyle/>
-          <a:p>
-            <a:pPr algn="l"/>
-            <a:r>
-              <a:rPr sz="1300" b="0">
+          <a:p>
+            <a:pPr algn="l">
+              <a:lnSpc>
+                <a:spcPct val="110000"/>
+              </a:lnSpc>
+              <a:spcBef>
+                <a:spcPts val="0"/>
+              </a:spcBef>
+              <a:spcAft>
+                <a:spcPts val="0"/>
+              </a:spcAft>
+            </a:pPr>
+            <a:r>
+              <a:rPr sz="1200">
                 <a:solidFill>
                   <a:srgbClr val="52667A"/>
                 </a:solidFill>
@@ -6913,7 +6669,7 @@
       </p:sp>
       <p:sp>
         <p:nvSpPr>
-          <p:cNvPr id="17" name="Rounded Rectangle 16"/>
+          <p:cNvPr id="8" name="Rounded Rectangle 7"/>
           <p:cNvSpPr/>
           <p:nvPr/>
         </p:nvSpPr>
@@ -6958,7 +6714,7 @@
       </p:sp>
       <p:sp>
         <p:nvSpPr>
-          <p:cNvPr id="18" name="TextBox 17"/>
+          <p:cNvPr id="9" name="TextBox 8"/>
           <p:cNvSpPr txBox="1"/>
           <p:nvPr/>
         </p:nvSpPr>
@@ -6993,7 +6749,7 @@
       </p:sp>
       <p:pic>
         <p:nvPicPr>
-          <p:cNvPr id="19" name="Picture 18" descr="platform-manage-data.png"/>
+          <p:cNvPr id="10" name="Picture 9" descr="platform-manage-data.png"/>
           <p:cNvPicPr>
             <a:picLocks noChangeAspect="1"/>
           </p:cNvPicPr>
@@ -7017,7 +6773,7 @@
       </p:pic>
       <p:sp>
         <p:nvSpPr>
-          <p:cNvPr id="20" name="TextBox 19"/>
+          <p:cNvPr id="11" name="TextBox 10"/>
           <p:cNvSpPr txBox="1"/>
           <p:nvPr/>
         </p:nvSpPr>
@@ -7052,7 +6808,7 @@
       </p:sp>
       <p:sp>
         <p:nvSpPr>
-          <p:cNvPr id="21" name="TextBox 20"/>
+          <p:cNvPr id="12" name="TextBox 11"/>
           <p:cNvSpPr txBox="1"/>
           <p:nvPr/>
         </p:nvSpPr>
@@ -7325,7 +7081,7 @@
         <p:spPr>
           <a:xfrm>
             <a:off x="749808" y="1097280"/>
-            <a:ext cx="4023360" cy="256032"/>
+            <a:ext cx="3931920" cy="4754880"/>
           </a:xfrm>
           <a:prstGeom prst="rect">
             <a:avLst/>
@@ -7333,12 +7089,19 @@
           <a:noFill/>
         </p:spPr>
         <p:txBody>
-          <a:bodyPr wrap="square" anchor="t">
+          <a:bodyPr wrap="square" lIns="0" rIns="0" tIns="0" bIns="0">
             <a:spAutoFit/>
           </a:bodyPr>
           <a:lstStyle/>
           <a:p>
-            <a:pPr algn="l"/>
+            <a:pPr algn="l">
+              <a:spcBef>
+                <a:spcPts val="0"/>
+              </a:spcBef>
+              <a:spcAft>
+                <a:spcPts val="200"/>
+              </a:spcAft>
+            </a:pPr>
             <a:r>
               <a:rPr sz="1200" b="1">
                 <a:solidFill>
@@ -7349,33 +7112,20 @@
               <a:t>User action</a:t>
             </a:r>
           </a:p>
-        </p:txBody>
-      </p:sp>
-      <p:sp>
-        <p:nvSpPr>
-          <p:cNvPr id="8" name="TextBox 7"/>
-          <p:cNvSpPr txBox="1"/>
-          <p:nvPr/>
-        </p:nvSpPr>
-        <p:spPr>
-          <a:xfrm>
-            <a:off x="749808" y="1353312"/>
-            <a:ext cx="3931920" cy="621792"/>
-          </a:xfrm>
-          <a:prstGeom prst="rect">
-            <a:avLst/>
-          </a:prstGeom>
-          <a:noFill/>
-        </p:spPr>
-        <p:txBody>
-          <a:bodyPr wrap="square" anchor="t">
-            <a:spAutoFit/>
-          </a:bodyPr>
-          <a:lstStyle/>
-          <a:p>
-            <a:pPr algn="l"/>
-            <a:r>
-              <a:rPr sz="1600" b="0">
+          <a:p>
+            <a:pPr algn="l">
+              <a:lnSpc>
+                <a:spcPct val="110000"/>
+              </a:lnSpc>
+              <a:spcBef>
+                <a:spcPts val="0"/>
+              </a:spcBef>
+              <a:spcAft>
+                <a:spcPts val="800"/>
+              </a:spcAft>
+            </a:pPr>
+            <a:r>
+              <a:rPr sz="1200">
                 <a:solidFill>
                   <a:srgbClr val="102A43"/>
                 </a:solidFill>
@@ -7384,31 +7134,15 @@
               <a:t>Assign or confirm field reps, then let a field rep authenticate into the Gmail/manual share flow or signed SSO entry point and send a doctor-facing WhatsApp message.</a:t>
             </a:r>
           </a:p>
-        </p:txBody>
-      </p:sp>
-      <p:sp>
-        <p:nvSpPr>
-          <p:cNvPr id="9" name="TextBox 8"/>
-          <p:cNvSpPr txBox="1"/>
-          <p:nvPr/>
-        </p:nvSpPr>
-        <p:spPr>
-          <a:xfrm>
-            <a:off x="749808" y="2011680"/>
-            <a:ext cx="4023360" cy="256032"/>
-          </a:xfrm>
-          <a:prstGeom prst="rect">
-            <a:avLst/>
-          </a:prstGeom>
-          <a:noFill/>
-        </p:spPr>
-        <p:txBody>
-          <a:bodyPr wrap="square" anchor="t">
-            <a:spAutoFit/>
-          </a:bodyPr>
-          <a:lstStyle/>
-          <a:p>
-            <a:pPr algn="l"/>
+          <a:p>
+            <a:pPr algn="l">
+              <a:spcBef>
+                <a:spcPts val="0"/>
+              </a:spcBef>
+              <a:spcAft>
+                <a:spcPts val="200"/>
+              </a:spcAft>
+            </a:pPr>
             <a:r>
               <a:rPr sz="1200" b="1">
                 <a:solidFill>
@@ -7419,33 +7153,20 @@
               <a:t>What appears on screen</a:t>
             </a:r>
           </a:p>
-        </p:txBody>
-      </p:sp>
-      <p:sp>
-        <p:nvSpPr>
-          <p:cNvPr id="10" name="TextBox 9"/>
-          <p:cNvSpPr txBox="1"/>
-          <p:nvPr/>
-        </p:nvSpPr>
-        <p:spPr>
-          <a:xfrm>
-            <a:off x="749808" y="2267712"/>
-            <a:ext cx="3931920" cy="713232"/>
-          </a:xfrm>
-          <a:prstGeom prst="rect">
-            <a:avLst/>
-          </a:prstGeom>
-          <a:noFill/>
-        </p:spPr>
-        <p:txBody>
-          <a:bodyPr wrap="square" anchor="t">
-            <a:spAutoFit/>
-          </a:bodyPr>
-          <a:lstStyle/>
-          <a:p>
-            <a:pPr algn="l"/>
-            <a:r>
-              <a:rPr sz="1600" b="0">
+          <a:p>
+            <a:pPr algn="l">
+              <a:lnSpc>
+                <a:spcPct val="110000"/>
+              </a:lnSpc>
+              <a:spcBef>
+                <a:spcPts val="0"/>
+              </a:spcBef>
+              <a:spcAft>
+                <a:spcPts val="800"/>
+              </a:spcAft>
+            </a:pPr>
+            <a:r>
+              <a:rPr sz="1200">
                 <a:solidFill>
                   <a:srgbClr val="102A43"/>
                 </a:solidFill>
@@ -7454,31 +7175,15 @@
               <a:t>Campaign-specific collateral options, doctor lists, send/reminder statuses, and the floating support chatbot on the field-rep pages.</a:t>
             </a:r>
           </a:p>
-        </p:txBody>
-      </p:sp>
-      <p:sp>
-        <p:nvSpPr>
-          <p:cNvPr id="11" name="TextBox 10"/>
-          <p:cNvSpPr txBox="1"/>
-          <p:nvPr/>
-        </p:nvSpPr>
-        <p:spPr>
-          <a:xfrm>
-            <a:off x="749808" y="3063240"/>
-            <a:ext cx="4023360" cy="256032"/>
-          </a:xfrm>
-          <a:prstGeom prst="rect">
-            <a:avLst/>
-          </a:prstGeom>
-          <a:noFill/>
-        </p:spPr>
-        <p:txBody>
-          <a:bodyPr wrap="square" anchor="t">
-            <a:spAutoFit/>
-          </a:bodyPr>
-          <a:lstStyle/>
-          <a:p>
-            <a:pPr algn="l"/>
+          <a:p>
+            <a:pPr algn="l">
+              <a:spcBef>
+                <a:spcPts val="0"/>
+              </a:spcBef>
+              <a:spcAft>
+                <a:spcPts val="200"/>
+              </a:spcAft>
+            </a:pPr>
             <a:r>
               <a:rPr sz="1200" b="1">
                 <a:solidFill>
@@ -7489,33 +7194,20 @@
               <a:t>Why it matters</a:t>
             </a:r>
           </a:p>
-        </p:txBody>
-      </p:sp>
-      <p:sp>
-        <p:nvSpPr>
-          <p:cNvPr id="12" name="TextBox 11"/>
-          <p:cNvSpPr txBox="1"/>
-          <p:nvPr/>
-        </p:nvSpPr>
-        <p:spPr>
-          <a:xfrm>
-            <a:off x="749808" y="3319272"/>
-            <a:ext cx="3931920" cy="640080"/>
-          </a:xfrm>
-          <a:prstGeom prst="rect">
-            <a:avLst/>
-          </a:prstGeom>
-          <a:noFill/>
-        </p:spPr>
-        <p:txBody>
-          <a:bodyPr wrap="square" anchor="t">
-            <a:spAutoFit/>
-          </a:bodyPr>
-          <a:lstStyle/>
-          <a:p>
-            <a:pPr algn="l"/>
-            <a:r>
-              <a:rPr sz="1500" b="0">
+          <a:p>
+            <a:pPr algn="l">
+              <a:lnSpc>
+                <a:spcPct val="110000"/>
+              </a:lnSpc>
+              <a:spcBef>
+                <a:spcPts val="0"/>
+              </a:spcBef>
+              <a:spcAft>
+                <a:spcPts val="800"/>
+              </a:spcAft>
+            </a:pPr>
+            <a:r>
+              <a:rPr sz="1200">
                 <a:solidFill>
                   <a:srgbClr val="102A43"/>
                 </a:solidFill>
@@ -7524,31 +7216,15 @@
               <a:t>This is the commercial and educational delivery loop the platform is built to support.</a:t>
             </a:r>
           </a:p>
-        </p:txBody>
-      </p:sp>
-      <p:sp>
-        <p:nvSpPr>
-          <p:cNvPr id="13" name="TextBox 12"/>
-          <p:cNvSpPr txBox="1"/>
-          <p:nvPr/>
-        </p:nvSpPr>
-        <p:spPr>
-          <a:xfrm>
-            <a:off x="749808" y="4069080"/>
-            <a:ext cx="4023360" cy="256032"/>
-          </a:xfrm>
-          <a:prstGeom prst="rect">
-            <a:avLst/>
-          </a:prstGeom>
-          <a:noFill/>
-        </p:spPr>
-        <p:txBody>
-          <a:bodyPr wrap="square" anchor="t">
-            <a:spAutoFit/>
-          </a:bodyPr>
-          <a:lstStyle/>
-          <a:p>
-            <a:pPr algn="l"/>
+          <a:p>
+            <a:pPr algn="l">
+              <a:spcBef>
+                <a:spcPts val="0"/>
+              </a:spcBef>
+              <a:spcAft>
+                <a:spcPts val="200"/>
+              </a:spcAft>
+            </a:pPr>
             <a:r>
               <a:rPr sz="1200" b="1">
                 <a:solidFill>
@@ -7559,33 +7235,20 @@
               <a:t>Expected result</a:t>
             </a:r>
           </a:p>
-        </p:txBody>
-      </p:sp>
-      <p:sp>
-        <p:nvSpPr>
-          <p:cNvPr id="14" name="TextBox 13"/>
-          <p:cNvSpPr txBox="1"/>
-          <p:nvPr/>
-        </p:nvSpPr>
-        <p:spPr>
-          <a:xfrm>
-            <a:off x="749808" y="4325112"/>
-            <a:ext cx="3931920" cy="566928"/>
-          </a:xfrm>
-          <a:prstGeom prst="rect">
-            <a:avLst/>
-          </a:prstGeom>
-          <a:noFill/>
-        </p:spPr>
-        <p:txBody>
-          <a:bodyPr wrap="square" anchor="t">
-            <a:spAutoFit/>
-          </a:bodyPr>
-          <a:lstStyle/>
-          <a:p>
-            <a:pPr algn="l"/>
-            <a:r>
-              <a:rPr sz="1500" b="0">
+          <a:p>
+            <a:pPr algn="l">
+              <a:lnSpc>
+                <a:spcPct val="110000"/>
+              </a:lnSpc>
+              <a:spcBef>
+                <a:spcPts val="0"/>
+              </a:spcBef>
+              <a:spcAft>
+                <a:spcPts val="800"/>
+              </a:spcAft>
+            </a:pPr>
+            <a:r>
+              <a:rPr sz="1200">
                 <a:solidFill>
                   <a:srgbClr val="102A43"/>
                 </a:solidFill>
@@ -7594,31 +7257,15 @@
               <a:t>A doctor receives a short link tied back to the right collateral, campaign, and rep.</a:t>
             </a:r>
           </a:p>
-        </p:txBody>
-      </p:sp>
-      <p:sp>
-        <p:nvSpPr>
-          <p:cNvPr id="15" name="TextBox 14"/>
-          <p:cNvSpPr txBox="1"/>
-          <p:nvPr/>
-        </p:nvSpPr>
-        <p:spPr>
-          <a:xfrm>
-            <a:off x="749808" y="4965192"/>
-            <a:ext cx="4023360" cy="256032"/>
-          </a:xfrm>
-          <a:prstGeom prst="rect">
-            <a:avLst/>
-          </a:prstGeom>
-          <a:noFill/>
-        </p:spPr>
-        <p:txBody>
-          <a:bodyPr wrap="square" anchor="t">
-            <a:spAutoFit/>
-          </a:bodyPr>
-          <a:lstStyle/>
-          <a:p>
-            <a:pPr algn="l"/>
+          <a:p>
+            <a:pPr algn="l">
+              <a:spcBef>
+                <a:spcPts val="0"/>
+              </a:spcBef>
+              <a:spcAft>
+                <a:spcPts val="200"/>
+              </a:spcAft>
+            </a:pPr>
             <a:r>
               <a:rPr sz="1200" b="1">
                 <a:solidFill>
@@ -7629,33 +7276,20 @@
               <a:t>Trainer note</a:t>
             </a:r>
           </a:p>
-        </p:txBody>
-      </p:sp>
-      <p:sp>
-        <p:nvSpPr>
-          <p:cNvPr id="16" name="TextBox 15"/>
-          <p:cNvSpPr txBox="1"/>
-          <p:nvPr/>
-        </p:nvSpPr>
-        <p:spPr>
-          <a:xfrm>
-            <a:off x="749808" y="5212080"/>
-            <a:ext cx="3931920" cy="640080"/>
-          </a:xfrm>
-          <a:prstGeom prst="rect">
-            <a:avLst/>
-          </a:prstGeom>
-          <a:noFill/>
-        </p:spPr>
-        <p:txBody>
-          <a:bodyPr wrap="square" anchor="t">
-            <a:spAutoFit/>
-          </a:bodyPr>
-          <a:lstStyle/>
-          <a:p>
-            <a:pPr algn="l"/>
-            <a:r>
-              <a:rPr sz="1300" b="0">
+          <a:p>
+            <a:pPr algn="l">
+              <a:lnSpc>
+                <a:spcPct val="110000"/>
+              </a:lnSpc>
+              <a:spcBef>
+                <a:spcPts val="0"/>
+              </a:spcBef>
+              <a:spcAft>
+                <a:spcPts val="0"/>
+              </a:spcAft>
+            </a:pPr>
+            <a:r>
+              <a:rPr sz="1100">
                 <a:solidFill>
                   <a:srgbClr val="52667A"/>
                 </a:solidFill>
@@ -7668,7 +7302,7 @@
       </p:sp>
       <p:sp>
         <p:nvSpPr>
-          <p:cNvPr id="17" name="Rounded Rectangle 16"/>
+          <p:cNvPr id="8" name="Rounded Rectangle 7"/>
           <p:cNvSpPr/>
           <p:nvPr/>
         </p:nvSpPr>
@@ -7713,7 +7347,7 @@
       </p:sp>
       <p:sp>
         <p:nvSpPr>
-          <p:cNvPr id="18" name="TextBox 17"/>
+          <p:cNvPr id="9" name="TextBox 8"/>
           <p:cNvSpPr txBox="1"/>
           <p:nvPr/>
         </p:nvSpPr>
@@ -7748,7 +7382,7 @@
       </p:sp>
       <p:pic>
         <p:nvPicPr>
-          <p:cNvPr id="19" name="Picture 18" descr="platform-share-handoff.png"/>
+          <p:cNvPr id="10" name="Picture 9" descr="platform-share-handoff.png"/>
           <p:cNvPicPr>
             <a:picLocks noChangeAspect="1"/>
           </p:cNvPicPr>
@@ -7772,7 +7406,7 @@
       </p:pic>
       <p:sp>
         <p:nvSpPr>
-          <p:cNvPr id="20" name="TextBox 19"/>
+          <p:cNvPr id="11" name="TextBox 10"/>
           <p:cNvSpPr txBox="1"/>
           <p:nvPr/>
         </p:nvSpPr>
@@ -7807,7 +7441,7 @@
       </p:sp>
       <p:sp>
         <p:nvSpPr>
-          <p:cNvPr id="21" name="TextBox 20"/>
+          <p:cNvPr id="12" name="TextBox 11"/>
           <p:cNvSpPr txBox="1"/>
           <p:nvPr/>
         </p:nvSpPr>
@@ -8080,7 +7714,7 @@
         <p:spPr>
           <a:xfrm>
             <a:off x="749808" y="1097280"/>
-            <a:ext cx="4023360" cy="256032"/>
+            <a:ext cx="3931920" cy="4754880"/>
           </a:xfrm>
           <a:prstGeom prst="rect">
             <a:avLst/>
@@ -8088,12 +7722,19 @@
           <a:noFill/>
         </p:spPr>
         <p:txBody>
-          <a:bodyPr wrap="square" anchor="t">
+          <a:bodyPr wrap="square" lIns="0" rIns="0" tIns="0" bIns="0">
             <a:spAutoFit/>
           </a:bodyPr>
           <a:lstStyle/>
           <a:p>
-            <a:pPr algn="l"/>
+            <a:pPr algn="l">
+              <a:spcBef>
+                <a:spcPts val="0"/>
+              </a:spcBef>
+              <a:spcAft>
+                <a:spcPts val="200"/>
+              </a:spcAft>
+            </a:pPr>
             <a:r>
               <a:rPr sz="1200" b="1">
                 <a:solidFill>
@@ -8104,33 +7745,20 @@
               <a:t>User action</a:t>
             </a:r>
           </a:p>
-        </p:txBody>
-      </p:sp>
-      <p:sp>
-        <p:nvSpPr>
-          <p:cNvPr id="8" name="TextBox 7"/>
-          <p:cNvSpPr txBox="1"/>
-          <p:nvPr/>
-        </p:nvSpPr>
-        <p:spPr>
-          <a:xfrm>
-            <a:off x="749808" y="1353312"/>
-            <a:ext cx="3931920" cy="621792"/>
-          </a:xfrm>
-          <a:prstGeom prst="rect">
-            <a:avLst/>
-          </a:prstGeom>
-          <a:noFill/>
-        </p:spPr>
-        <p:txBody>
-          <a:bodyPr wrap="square" anchor="t">
-            <a:spAutoFit/>
-          </a:bodyPr>
-          <a:lstStyle/>
-          <a:p>
-            <a:pPr algn="l"/>
-            <a:r>
-              <a:rPr sz="1600" b="0">
+          <a:p>
+            <a:pPr algn="l">
+              <a:lnSpc>
+                <a:spcPct val="110000"/>
+              </a:lnSpc>
+              <a:spcBef>
+                <a:spcPts val="0"/>
+              </a:spcBef>
+              <a:spcAft>
+                <a:spcPts val="800"/>
+              </a:spcAft>
+            </a:pPr>
+            <a:r>
+              <a:rPr sz="1200">
                 <a:solidFill>
                   <a:srgbClr val="102A43"/>
                 </a:solidFill>
@@ -8139,31 +7767,15 @@
               <a:t>Follow the doctor from short-link click to verification, then open the transaction dashboard for the same campaign.</a:t>
             </a:r>
           </a:p>
-        </p:txBody>
-      </p:sp>
-      <p:sp>
-        <p:nvSpPr>
-          <p:cNvPr id="9" name="TextBox 8"/>
-          <p:cNvSpPr txBox="1"/>
-          <p:nvPr/>
-        </p:nvSpPr>
-        <p:spPr>
-          <a:xfrm>
-            <a:off x="749808" y="2011680"/>
-            <a:ext cx="4023360" cy="256032"/>
-          </a:xfrm>
-          <a:prstGeom prst="rect">
-            <a:avLst/>
-          </a:prstGeom>
-          <a:noFill/>
-        </p:spPr>
-        <p:txBody>
-          <a:bodyPr wrap="square" anchor="t">
-            <a:spAutoFit/>
-          </a:bodyPr>
-          <a:lstStyle/>
-          <a:p>
-            <a:pPr algn="l"/>
+          <a:p>
+            <a:pPr algn="l">
+              <a:spcBef>
+                <a:spcPts val="0"/>
+              </a:spcBef>
+              <a:spcAft>
+                <a:spcPts val="200"/>
+              </a:spcAft>
+            </a:pPr>
             <a:r>
               <a:rPr sz="1200" b="1">
                 <a:solidFill>
@@ -8174,33 +7786,20 @@
               <a:t>What appears on screen</a:t>
             </a:r>
           </a:p>
-        </p:txBody>
-      </p:sp>
-      <p:sp>
-        <p:nvSpPr>
-          <p:cNvPr id="10" name="TextBox 9"/>
-          <p:cNvSpPr txBox="1"/>
-          <p:nvPr/>
-        </p:nvSpPr>
-        <p:spPr>
-          <a:xfrm>
-            <a:off x="749808" y="2267712"/>
-            <a:ext cx="3931920" cy="713232"/>
-          </a:xfrm>
-          <a:prstGeom prst="rect">
-            <a:avLst/>
-          </a:prstGeom>
-          <a:noFill/>
-        </p:spPr>
-        <p:txBody>
-          <a:bodyPr wrap="square" anchor="t">
-            <a:spAutoFit/>
-          </a:bodyPr>
-          <a:lstStyle/>
-          <a:p>
-            <a:pPr algn="l"/>
-            <a:r>
-              <a:rPr sz="1600" b="0">
+          <a:p>
+            <a:pPr algn="l">
+              <a:lnSpc>
+                <a:spcPct val="110000"/>
+              </a:lnSpc>
+              <a:spcBef>
+                <a:spcPts val="0"/>
+              </a:spcBef>
+              <a:spcAft>
+                <a:spcPts val="800"/>
+              </a:spcAft>
+            </a:pPr>
+            <a:r>
+              <a:rPr sz="1200">
                 <a:solidFill>
                   <a:srgbClr val="102A43"/>
                 </a:solidFill>
@@ -8209,31 +7808,15 @@
               <a:t>The doctor unlock screen, the collateral viewer with PDF/archive/webinar content and support chatbot, and a reporting dashboard summarizing doctor-level outcomes.</a:t>
             </a:r>
           </a:p>
-        </p:txBody>
-      </p:sp>
-      <p:sp>
-        <p:nvSpPr>
-          <p:cNvPr id="11" name="TextBox 10"/>
-          <p:cNvSpPr txBox="1"/>
-          <p:nvPr/>
-        </p:nvSpPr>
-        <p:spPr>
-          <a:xfrm>
-            <a:off x="749808" y="3063240"/>
-            <a:ext cx="4023360" cy="256032"/>
-          </a:xfrm>
-          <a:prstGeom prst="rect">
-            <a:avLst/>
-          </a:prstGeom>
-          <a:noFill/>
-        </p:spPr>
-        <p:txBody>
-          <a:bodyPr wrap="square" anchor="t">
-            <a:spAutoFit/>
-          </a:bodyPr>
-          <a:lstStyle/>
-          <a:p>
-            <a:pPr algn="l"/>
+          <a:p>
+            <a:pPr algn="l">
+              <a:spcBef>
+                <a:spcPts val="0"/>
+              </a:spcBef>
+              <a:spcAft>
+                <a:spcPts val="200"/>
+              </a:spcAft>
+            </a:pPr>
             <a:r>
               <a:rPr sz="1200" b="1">
                 <a:solidFill>
@@ -8244,33 +7827,20 @@
               <a:t>Why it matters</a:t>
             </a:r>
           </a:p>
-        </p:txBody>
-      </p:sp>
-      <p:sp>
-        <p:nvSpPr>
-          <p:cNvPr id="12" name="TextBox 11"/>
-          <p:cNvSpPr txBox="1"/>
-          <p:nvPr/>
-        </p:nvSpPr>
-        <p:spPr>
-          <a:xfrm>
-            <a:off x="749808" y="3319272"/>
-            <a:ext cx="3931920" cy="640080"/>
-          </a:xfrm>
-          <a:prstGeom prst="rect">
-            <a:avLst/>
-          </a:prstGeom>
-          <a:noFill/>
-        </p:spPr>
-        <p:txBody>
-          <a:bodyPr wrap="square" anchor="t">
-            <a:spAutoFit/>
-          </a:bodyPr>
-          <a:lstStyle/>
-          <a:p>
-            <a:pPr algn="l"/>
-            <a:r>
-              <a:rPr sz="1500" b="0">
+          <a:p>
+            <a:pPr algn="l">
+              <a:lnSpc>
+                <a:spcPct val="110000"/>
+              </a:lnSpc>
+              <a:spcBef>
+                <a:spcPts val="0"/>
+              </a:spcBef>
+              <a:spcAft>
+                <a:spcPts val="800"/>
+              </a:spcAft>
+            </a:pPr>
+            <a:r>
+              <a:rPr sz="1200">
                 <a:solidFill>
                   <a:srgbClr val="102A43"/>
                 </a:solidFill>
@@ -8279,31 +7849,15 @@
               <a:t>The product is not just a file host; it exists to connect campaign setup to verifiable doctor engagement.</a:t>
             </a:r>
           </a:p>
-        </p:txBody>
-      </p:sp>
-      <p:sp>
-        <p:nvSpPr>
-          <p:cNvPr id="13" name="TextBox 12"/>
-          <p:cNvSpPr txBox="1"/>
-          <p:nvPr/>
-        </p:nvSpPr>
-        <p:spPr>
-          <a:xfrm>
-            <a:off x="749808" y="4069080"/>
-            <a:ext cx="4023360" cy="256032"/>
-          </a:xfrm>
-          <a:prstGeom prst="rect">
-            <a:avLst/>
-          </a:prstGeom>
-          <a:noFill/>
-        </p:spPr>
-        <p:txBody>
-          <a:bodyPr wrap="square" anchor="t">
-            <a:spAutoFit/>
-          </a:bodyPr>
-          <a:lstStyle/>
-          <a:p>
-            <a:pPr algn="l"/>
+          <a:p>
+            <a:pPr algn="l">
+              <a:spcBef>
+                <a:spcPts val="0"/>
+              </a:spcBef>
+              <a:spcAft>
+                <a:spcPts val="200"/>
+              </a:spcAft>
+            </a:pPr>
             <a:r>
               <a:rPr sz="1200" b="1">
                 <a:solidFill>
@@ -8314,33 +7868,20 @@
               <a:t>Expected result</a:t>
             </a:r>
           </a:p>
-        </p:txBody>
-      </p:sp>
-      <p:sp>
-        <p:nvSpPr>
-          <p:cNvPr id="14" name="TextBox 13"/>
-          <p:cNvSpPr txBox="1"/>
-          <p:nvPr/>
-        </p:nvSpPr>
-        <p:spPr>
-          <a:xfrm>
-            <a:off x="749808" y="4325112"/>
-            <a:ext cx="3931920" cy="566928"/>
-          </a:xfrm>
-          <a:prstGeom prst="rect">
-            <a:avLst/>
-          </a:prstGeom>
-          <a:noFill/>
-        </p:spPr>
-        <p:txBody>
-          <a:bodyPr wrap="square" anchor="t">
-            <a:spAutoFit/>
-          </a:bodyPr>
-          <a:lstStyle/>
-          <a:p>
-            <a:pPr algn="l"/>
-            <a:r>
-              <a:rPr sz="1500" b="0">
+          <a:p>
+            <a:pPr algn="l">
+              <a:lnSpc>
+                <a:spcPct val="110000"/>
+              </a:lnSpc>
+              <a:spcBef>
+                <a:spcPts val="0"/>
+              </a:spcBef>
+              <a:spcAft>
+                <a:spcPts val="800"/>
+              </a:spcAft>
+            </a:pPr>
+            <a:r>
+              <a:rPr sz="1200">
                 <a:solidFill>
                   <a:srgbClr val="102A43"/>
                 </a:solidFill>
@@ -8349,31 +7890,15 @@
               <a:t>Doctor actions are visible again in reporting and can drive follow-up conversations.</a:t>
             </a:r>
           </a:p>
-        </p:txBody>
-      </p:sp>
-      <p:sp>
-        <p:nvSpPr>
-          <p:cNvPr id="15" name="TextBox 14"/>
-          <p:cNvSpPr txBox="1"/>
-          <p:nvPr/>
-        </p:nvSpPr>
-        <p:spPr>
-          <a:xfrm>
-            <a:off x="749808" y="4965192"/>
-            <a:ext cx="4023360" cy="256032"/>
-          </a:xfrm>
-          <a:prstGeom prst="rect">
-            <a:avLst/>
-          </a:prstGeom>
-          <a:noFill/>
-        </p:spPr>
-        <p:txBody>
-          <a:bodyPr wrap="square" anchor="t">
-            <a:spAutoFit/>
-          </a:bodyPr>
-          <a:lstStyle/>
-          <a:p>
-            <a:pPr algn="l"/>
+          <a:p>
+            <a:pPr algn="l">
+              <a:spcBef>
+                <a:spcPts val="0"/>
+              </a:spcBef>
+              <a:spcAft>
+                <a:spcPts val="200"/>
+              </a:spcAft>
+            </a:pPr>
             <a:r>
               <a:rPr sz="1200" b="1">
                 <a:solidFill>
@@ -8384,33 +7909,20 @@
               <a:t>Trainer note</a:t>
             </a:r>
           </a:p>
-        </p:txBody>
-      </p:sp>
-      <p:sp>
-        <p:nvSpPr>
-          <p:cNvPr id="16" name="TextBox 15"/>
-          <p:cNvSpPr txBox="1"/>
-          <p:nvPr/>
-        </p:nvSpPr>
-        <p:spPr>
-          <a:xfrm>
-            <a:off x="749808" y="5212080"/>
-            <a:ext cx="3931920" cy="640080"/>
-          </a:xfrm>
-          <a:prstGeom prst="rect">
-            <a:avLst/>
-          </a:prstGeom>
-          <a:noFill/>
-        </p:spPr>
-        <p:txBody>
-          <a:bodyPr wrap="square" anchor="t">
-            <a:spAutoFit/>
-          </a:bodyPr>
-          <a:lstStyle/>
-          <a:p>
-            <a:pPr algn="l"/>
-            <a:r>
-              <a:rPr sz="1300" b="0">
+          <a:p>
+            <a:pPr algn="l">
+              <a:lnSpc>
+                <a:spcPct val="110000"/>
+              </a:lnSpc>
+              <a:spcBef>
+                <a:spcPts val="0"/>
+              </a:spcBef>
+              <a:spcAft>
+                <a:spcPts val="0"/>
+              </a:spcAft>
+            </a:pPr>
+            <a:r>
+              <a:rPr sz="1100">
                 <a:solidFill>
                   <a:srgbClr val="52667A"/>
                 </a:solidFill>
@@ -8423,7 +7935,7 @@
       </p:sp>
       <p:sp>
         <p:nvSpPr>
-          <p:cNvPr id="17" name="Rounded Rectangle 16"/>
+          <p:cNvPr id="8" name="Rounded Rectangle 7"/>
           <p:cNvSpPr/>
           <p:nvPr/>
         </p:nvSpPr>
@@ -8468,7 +7980,7 @@
       </p:sp>
       <p:sp>
         <p:nvSpPr>
-          <p:cNvPr id="18" name="TextBox 17"/>
+          <p:cNvPr id="9" name="TextBox 8"/>
           <p:cNvSpPr txBox="1"/>
           <p:nvPr/>
         </p:nvSpPr>
@@ -8503,7 +8015,7 @@
       </p:sp>
       <p:pic>
         <p:nvPicPr>
-          <p:cNvPr id="19" name="Picture 18" descr="platform-reporting-loop.png"/>
+          <p:cNvPr id="10" name="Picture 9" descr="platform-reporting-loop.png"/>
           <p:cNvPicPr>
             <a:picLocks noChangeAspect="1"/>
           </p:cNvPicPr>
@@ -8527,7 +8039,7 @@
       </p:pic>
       <p:sp>
         <p:nvSpPr>
-          <p:cNvPr id="20" name="TextBox 19"/>
+          <p:cNvPr id="11" name="TextBox 10"/>
           <p:cNvSpPr txBox="1"/>
           <p:nvPr/>
         </p:nvSpPr>
@@ -8562,7 +8074,7 @@
       </p:sp>
       <p:sp>
         <p:nvSpPr>
-          <p:cNvPr id="21" name="TextBox 20"/>
+          <p:cNvPr id="12" name="TextBox 11"/>
           <p:cNvSpPr txBox="1"/>
           <p:nvPr/>
         </p:nvSpPr>

</xml_diff>